<commit_message>
Simplify defense presentation deck
Co-authored-by: daniyal.jamal <daniyal.jamal@heptasoftwaresolutions.com>
</commit_message>
<xml_diff>
--- a/Final_Defense_Presentation.pptx
+++ b/Final_Defense_Presentation.pptx
@@ -17,11 +17,6 @@
     <p:sldId id="265" r:id="rId16"/>
     <p:sldId id="266" r:id="rId17"/>
     <p:sldId id="267" r:id="rId18"/>
-    <p:sldId id="268" r:id="rId19"/>
-    <p:sldId id="269" r:id="rId20"/>
-    <p:sldId id="270" r:id="rId21"/>
-    <p:sldId id="271" r:id="rId22"/>
-    <p:sldId id="272" r:id="rId23"/>
   </p:sldIdLst>
   <p:sldSz cx="12191695" cy="6858000" type="screen4x3"/>
   <p:notesSz cx="6858000" cy="9144000"/>
@@ -3125,7 +3120,7 @@
                   <a:srgbClr val="1F4E79"/>
                 </a:solidFill>
               </a:rPr>
-              <a:t>A Novel Approach to Secure Execution in Embedded Systems</a:t>
+              <a:t>Secure Execution in Embedded Systems</a:t>
             </a:r>
           </a:p>
         </p:txBody>
@@ -3147,7 +3142,7 @@
           <a:p>
             <a:r>
               <a:rPr sz="2000"/>
-              <a:t>Custom ISA and Compiler Binding</a:t>
+              <a:t>Custom ISA + Compiler Binding</a:t>
             </a:r>
           </a:p>
           <a:p>
@@ -3239,58 +3234,59 @@
                   <a:srgbClr val="1F4E79"/>
                 </a:solidFill>
               </a:rPr>
-              <a:t>Evaluation Overview</a:t>
-            </a:r>
-          </a:p>
-        </p:txBody>
-      </p:sp>
-      <p:sp>
-        <p:nvSpPr>
-          <p:cNvPr id="4" name="TextBox 3"/>
-          <p:cNvSpPr txBox="1"/>
+              <a:t>Results: Authorization</a:t>
+            </a:r>
+          </a:p>
+        </p:txBody>
+      </p:sp>
+      <p:pic>
+        <p:nvPicPr>
+          <p:cNvPr id="4" name="Picture 3" descr="fig_keymatch.png"/>
+          <p:cNvPicPr>
+            <a:picLocks noChangeAspect="1"/>
+          </p:cNvPicPr>
           <p:nvPr/>
-        </p:nvSpPr>
+        </p:nvPicPr>
+        <p:blipFill>
+          <a:blip r:embed="rId2"/>
+          <a:stretch>
+            <a:fillRect/>
+          </a:stretch>
+        </p:blipFill>
         <p:spPr>
           <a:xfrm>
-            <a:off x="822960" y="1188720"/>
-            <a:ext cx="10545775" cy="5029200"/>
+            <a:off x="640080" y="914400"/>
+            <a:ext cx="10911535" cy="6583667"/>
           </a:xfrm>
           <a:prstGeom prst="rect">
             <a:avLst/>
           </a:prstGeom>
-          <a:noFill/>
         </p:spPr>
-        <p:txBody>
-          <a:bodyPr wrap="none">
-            <a:spAutoFit/>
-          </a:bodyPr>
-          <a:lstStyle/>
-          <a:p>
-            <a:pPr>
-              <a:defRPr sz="2200"/>
-            </a:pPr>
-            <a:r>
-              <a:t>Toolchain-level validation: compile, link, ELF-to-HEX</a:t>
-            </a:r>
-          </a:p>
-          <a:p>
-            <a:pPr>
-              <a:defRPr sz="2200"/>
-            </a:pPr>
-            <a:r>
-              <a:t>System-level validation: authorization gates execution and debug</a:t>
-            </a:r>
-          </a:p>
-          <a:p>
-            <a:pPr>
-              <a:defRPr sz="2200"/>
-            </a:pPr>
-            <a:r>
-              <a:t>Evidence collected from host logs and screenshots</a:t>
-            </a:r>
-          </a:p>
-        </p:txBody>
-      </p:sp>
+      </p:pic>
+      <p:pic>
+        <p:nvPicPr>
+          <p:cNvPr id="5" name="Picture 4" descr="fig_debugenabled.png"/>
+          <p:cNvPicPr>
+            <a:picLocks noChangeAspect="1"/>
+          </p:cNvPicPr>
+          <p:nvPr/>
+        </p:nvPicPr>
+        <p:blipFill>
+          <a:blip r:embed="rId3"/>
+          <a:stretch>
+            <a:fillRect/>
+          </a:stretch>
+        </p:blipFill>
+        <p:spPr>
+          <a:xfrm>
+            <a:off x="640080" y="7726667"/>
+            <a:ext cx="10911535" cy="6600298"/>
+          </a:xfrm>
+          <a:prstGeom prst="rect">
+            <a:avLst/>
+          </a:prstGeom>
+        </p:spPr>
+      </p:pic>
     </p:spTree>
   </p:cSld>
   <p:clrMapOvr>
@@ -3354,7 +3350,1052 @@
                   <a:srgbClr val="1F4E79"/>
                 </a:solidFill>
               </a:rPr>
-              <a:t>Results: Toolchain and Hex Inspection</a:t>
+              <a:t>Results: Programming</a:t>
+            </a:r>
+          </a:p>
+        </p:txBody>
+      </p:sp>
+      <p:pic>
+        <p:nvPicPr>
+          <p:cNvPr id="4" name="Picture 3" descr="fig_connected.png"/>
+          <p:cNvPicPr>
+            <a:picLocks noChangeAspect="1"/>
+          </p:cNvPicPr>
+          <p:nvPr/>
+        </p:nvPicPr>
+        <p:blipFill>
+          <a:blip r:embed="rId2"/>
+          <a:stretch>
+            <a:fillRect/>
+          </a:stretch>
+        </p:blipFill>
+        <p:spPr>
+          <a:xfrm>
+            <a:off x="640080" y="914400"/>
+            <a:ext cx="10911535" cy="7137749"/>
+          </a:xfrm>
+          <a:prstGeom prst="rect">
+            <a:avLst/>
+          </a:prstGeom>
+        </p:spPr>
+      </p:pic>
+      <p:pic>
+        <p:nvPicPr>
+          <p:cNvPr id="5" name="Picture 4" descr="fig_loadimage.png"/>
+          <p:cNvPicPr>
+            <a:picLocks noChangeAspect="1"/>
+          </p:cNvPicPr>
+          <p:nvPr/>
+        </p:nvPicPr>
+        <p:blipFill>
+          <a:blip r:embed="rId3"/>
+          <a:stretch>
+            <a:fillRect/>
+          </a:stretch>
+        </p:blipFill>
+        <p:spPr>
+          <a:xfrm>
+            <a:off x="640080" y="8280749"/>
+            <a:ext cx="10911535" cy="4971788"/>
+          </a:xfrm>
+          <a:prstGeom prst="rect">
+            <a:avLst/>
+          </a:prstGeom>
+        </p:spPr>
+      </p:pic>
+    </p:spTree>
+  </p:cSld>
+  <p:clrMapOvr>
+    <a:masterClrMapping/>
+  </p:clrMapOvr>
+</p:sld>
+</file>
+
+<file path=ppt/slides/slide12.xml><?xml version="1.0" encoding="utf-8"?>
+<p:sld xmlns:a="http://schemas.openxmlformats.org/drawingml/2006/main" xmlns:p="http://schemas.openxmlformats.org/presentationml/2006/main" xmlns:r="http://schemas.openxmlformats.org/officeDocument/2006/relationships">
+  <p:cSld>
+    <p:spTree>
+      <p:nvGrpSpPr>
+        <p:cNvPr id="1" name=""/>
+        <p:cNvGrpSpPr/>
+        <p:nvPr/>
+      </p:nvGrpSpPr>
+      <p:grpSpPr/>
+      <p:sp>
+        <p:nvSpPr>
+          <p:cNvPr id="2" name="Title 1"/>
+          <p:cNvSpPr>
+            <a:spLocks noGrp="1"/>
+          </p:cNvSpPr>
+          <p:nvPr>
+            <p:ph type="title"/>
+          </p:nvPr>
+        </p:nvSpPr>
+        <p:spPr/>
+        <p:txBody>
+          <a:bodyPr/>
+          <a:lstStyle/>
+          <a:p/>
+        </p:txBody>
+      </p:sp>
+      <p:sp>
+        <p:nvSpPr>
+          <p:cNvPr id="3" name="TextBox 2"/>
+          <p:cNvSpPr txBox="1"/>
+          <p:nvPr/>
+        </p:nvSpPr>
+        <p:spPr>
+          <a:xfrm>
+            <a:off x="457200" y="182880"/>
+            <a:ext cx="11277295" cy="548640"/>
+          </a:xfrm>
+          <a:prstGeom prst="rect">
+            <a:avLst/>
+          </a:prstGeom>
+          <a:noFill/>
+        </p:spPr>
+        <p:txBody>
+          <a:bodyPr wrap="none">
+            <a:spAutoFit/>
+          </a:bodyPr>
+          <a:lstStyle/>
+          <a:p>
+            <a:r>
+              <a:rPr sz="3600" b="1">
+                <a:solidFill>
+                  <a:srgbClr val="1F4E79"/>
+                </a:solidFill>
+              </a:rPr>
+              <a:t>Conclusion</a:t>
+            </a:r>
+          </a:p>
+        </p:txBody>
+      </p:sp>
+      <p:sp>
+        <p:nvSpPr>
+          <p:cNvPr id="4" name="TextBox 3"/>
+          <p:cNvSpPr txBox="1"/>
+          <p:nvPr/>
+        </p:nvSpPr>
+        <p:spPr>
+          <a:xfrm>
+            <a:off x="822960" y="1188720"/>
+            <a:ext cx="10545775" cy="5029200"/>
+          </a:xfrm>
+          <a:prstGeom prst="rect">
+            <a:avLst/>
+          </a:prstGeom>
+          <a:noFill/>
+        </p:spPr>
+        <p:txBody>
+          <a:bodyPr wrap="none">
+            <a:spAutoFit/>
+          </a:bodyPr>
+          <a:lstStyle/>
+          <a:p>
+            <a:pPr>
+              <a:defRPr sz="2400"/>
+            </a:pPr>
+            <a:r>
+              <a:t>Instruction-triggered authorization works</a:t>
+            </a:r>
+          </a:p>
+          <a:p>
+            <a:pPr>
+              <a:defRPr sz="2400"/>
+            </a:pPr>
+            <a:r>
+              <a:t>Execution and debug stay locked until verified</a:t>
+            </a:r>
+          </a:p>
+          <a:p>
+            <a:pPr>
+              <a:defRPr sz="2400"/>
+            </a:pPr>
+            <a:r>
+              <a:t>End-to-end workflow is practical</a:t>
+            </a:r>
+          </a:p>
+          <a:p>
+            <a:pPr>
+              <a:defRPr sz="2400"/>
+            </a:pPr>
+            <a:r>
+              <a:t>Questions?</a:t>
+            </a:r>
+          </a:p>
+        </p:txBody>
+      </p:sp>
+    </p:spTree>
+  </p:cSld>
+  <p:clrMapOvr>
+    <a:masterClrMapping/>
+  </p:clrMapOvr>
+</p:sld>
+</file>
+
+<file path=ppt/slides/slide2.xml><?xml version="1.0" encoding="utf-8"?>
+<p:sld xmlns:a="http://schemas.openxmlformats.org/drawingml/2006/main" xmlns:p="http://schemas.openxmlformats.org/presentationml/2006/main" xmlns:r="http://schemas.openxmlformats.org/officeDocument/2006/relationships">
+  <p:cSld>
+    <p:spTree>
+      <p:nvGrpSpPr>
+        <p:cNvPr id="1" name=""/>
+        <p:cNvGrpSpPr/>
+        <p:nvPr/>
+      </p:nvGrpSpPr>
+      <p:grpSpPr/>
+      <p:sp>
+        <p:nvSpPr>
+          <p:cNvPr id="2" name="Title 1"/>
+          <p:cNvSpPr>
+            <a:spLocks noGrp="1"/>
+          </p:cNvSpPr>
+          <p:nvPr>
+            <p:ph type="title"/>
+          </p:nvPr>
+        </p:nvSpPr>
+        <p:spPr/>
+        <p:txBody>
+          <a:bodyPr/>
+          <a:lstStyle/>
+          <a:p/>
+        </p:txBody>
+      </p:sp>
+      <p:sp>
+        <p:nvSpPr>
+          <p:cNvPr id="3" name="TextBox 2"/>
+          <p:cNvSpPr txBox="1"/>
+          <p:nvPr/>
+        </p:nvSpPr>
+        <p:spPr>
+          <a:xfrm>
+            <a:off x="457200" y="182880"/>
+            <a:ext cx="11277295" cy="548640"/>
+          </a:xfrm>
+          <a:prstGeom prst="rect">
+            <a:avLst/>
+          </a:prstGeom>
+          <a:noFill/>
+        </p:spPr>
+        <p:txBody>
+          <a:bodyPr wrap="none">
+            <a:spAutoFit/>
+          </a:bodyPr>
+          <a:lstStyle/>
+          <a:p>
+            <a:r>
+              <a:rPr sz="3600" b="1">
+                <a:solidFill>
+                  <a:srgbClr val="1F4E79"/>
+                </a:solidFill>
+              </a:rPr>
+              <a:t>Problem</a:t>
+            </a:r>
+          </a:p>
+        </p:txBody>
+      </p:sp>
+      <p:sp>
+        <p:nvSpPr>
+          <p:cNvPr id="4" name="TextBox 3"/>
+          <p:cNvSpPr txBox="1"/>
+          <p:nvPr/>
+        </p:nvSpPr>
+        <p:spPr>
+          <a:xfrm>
+            <a:off x="822960" y="1188720"/>
+            <a:ext cx="10545775" cy="5029200"/>
+          </a:xfrm>
+          <a:prstGeom prst="rect">
+            <a:avLst/>
+          </a:prstGeom>
+          <a:noFill/>
+        </p:spPr>
+        <p:txBody>
+          <a:bodyPr wrap="none">
+            <a:spAutoFit/>
+          </a:bodyPr>
+          <a:lstStyle/>
+          <a:p>
+            <a:pPr>
+              <a:defRPr sz="2400"/>
+            </a:pPr>
+            <a:r>
+              <a:t>Physical access allows firmware replacement</a:t>
+            </a:r>
+          </a:p>
+          <a:p>
+            <a:pPr>
+              <a:defRPr sz="2400"/>
+            </a:pPr>
+            <a:r>
+              <a:t>Debug interfaces give full control</a:t>
+            </a:r>
+          </a:p>
+          <a:p>
+            <a:pPr>
+              <a:defRPr sz="2400"/>
+            </a:pPr>
+            <a:r>
+              <a:t>Secure boot does not stop post-boot abuse</a:t>
+            </a:r>
+          </a:p>
+        </p:txBody>
+      </p:sp>
+    </p:spTree>
+  </p:cSld>
+  <p:clrMapOvr>
+    <a:masterClrMapping/>
+  </p:clrMapOvr>
+</p:sld>
+</file>
+
+<file path=ppt/slides/slide3.xml><?xml version="1.0" encoding="utf-8"?>
+<p:sld xmlns:a="http://schemas.openxmlformats.org/drawingml/2006/main" xmlns:p="http://schemas.openxmlformats.org/presentationml/2006/main" xmlns:r="http://schemas.openxmlformats.org/officeDocument/2006/relationships">
+  <p:cSld>
+    <p:spTree>
+      <p:nvGrpSpPr>
+        <p:cNvPr id="1" name=""/>
+        <p:cNvGrpSpPr/>
+        <p:nvPr/>
+      </p:nvGrpSpPr>
+      <p:grpSpPr/>
+      <p:sp>
+        <p:nvSpPr>
+          <p:cNvPr id="2" name="Title 1"/>
+          <p:cNvSpPr>
+            <a:spLocks noGrp="1"/>
+          </p:cNvSpPr>
+          <p:nvPr>
+            <p:ph type="title"/>
+          </p:nvPr>
+        </p:nvSpPr>
+        <p:spPr/>
+        <p:txBody>
+          <a:bodyPr/>
+          <a:lstStyle/>
+          <a:p/>
+        </p:txBody>
+      </p:sp>
+      <p:sp>
+        <p:nvSpPr>
+          <p:cNvPr id="3" name="TextBox 2"/>
+          <p:cNvSpPr txBox="1"/>
+          <p:nvPr/>
+        </p:nvSpPr>
+        <p:spPr>
+          <a:xfrm>
+            <a:off x="457200" y="182880"/>
+            <a:ext cx="11277295" cy="548640"/>
+          </a:xfrm>
+          <a:prstGeom prst="rect">
+            <a:avLst/>
+          </a:prstGeom>
+          <a:noFill/>
+        </p:spPr>
+        <p:txBody>
+          <a:bodyPr wrap="none">
+            <a:spAutoFit/>
+          </a:bodyPr>
+          <a:lstStyle/>
+          <a:p>
+            <a:r>
+              <a:rPr sz="3600" b="1">
+                <a:solidFill>
+                  <a:srgbClr val="1F4E79"/>
+                </a:solidFill>
+              </a:rPr>
+              <a:t>Goal</a:t>
+            </a:r>
+          </a:p>
+        </p:txBody>
+      </p:sp>
+      <p:sp>
+        <p:nvSpPr>
+          <p:cNvPr id="4" name="TextBox 3"/>
+          <p:cNvSpPr txBox="1"/>
+          <p:nvPr/>
+        </p:nvSpPr>
+        <p:spPr>
+          <a:xfrm>
+            <a:off x="822960" y="1188720"/>
+            <a:ext cx="10545775" cy="5029200"/>
+          </a:xfrm>
+          <a:prstGeom prst="rect">
+            <a:avLst/>
+          </a:prstGeom>
+          <a:noFill/>
+        </p:spPr>
+        <p:txBody>
+          <a:bodyPr wrap="none">
+            <a:spAutoFit/>
+          </a:bodyPr>
+          <a:lstStyle/>
+          <a:p>
+            <a:pPr>
+              <a:defRPr sz="2400"/>
+            </a:pPr>
+            <a:r>
+              <a:t>Only authorized users can program or debug</a:t>
+            </a:r>
+          </a:p>
+          <a:p>
+            <a:pPr>
+              <a:defRPr sz="2400"/>
+            </a:pPr>
+            <a:r>
+              <a:t>Device decides locally (not just the host)</a:t>
+            </a:r>
+          </a:p>
+          <a:p>
+            <a:pPr>
+              <a:defRPr sz="2400"/>
+            </a:pPr>
+            <a:r>
+              <a:t>Keys stay protected from normal memory reads</a:t>
+            </a:r>
+          </a:p>
+        </p:txBody>
+      </p:sp>
+    </p:spTree>
+  </p:cSld>
+  <p:clrMapOvr>
+    <a:masterClrMapping/>
+  </p:clrMapOvr>
+</p:sld>
+</file>
+
+<file path=ppt/slides/slide4.xml><?xml version="1.0" encoding="utf-8"?>
+<p:sld xmlns:a="http://schemas.openxmlformats.org/drawingml/2006/main" xmlns:p="http://schemas.openxmlformats.org/presentationml/2006/main" xmlns:r="http://schemas.openxmlformats.org/officeDocument/2006/relationships">
+  <p:cSld>
+    <p:spTree>
+      <p:nvGrpSpPr>
+        <p:cNvPr id="1" name=""/>
+        <p:cNvGrpSpPr/>
+        <p:nvPr/>
+      </p:nvGrpSpPr>
+      <p:grpSpPr/>
+      <p:sp>
+        <p:nvSpPr>
+          <p:cNvPr id="2" name="Title 1"/>
+          <p:cNvSpPr>
+            <a:spLocks noGrp="1"/>
+          </p:cNvSpPr>
+          <p:nvPr>
+            <p:ph type="title"/>
+          </p:nvPr>
+        </p:nvSpPr>
+        <p:spPr/>
+        <p:txBody>
+          <a:bodyPr/>
+          <a:lstStyle/>
+          <a:p/>
+        </p:txBody>
+      </p:sp>
+      <p:sp>
+        <p:nvSpPr>
+          <p:cNvPr id="3" name="TextBox 2"/>
+          <p:cNvSpPr txBox="1"/>
+          <p:nvPr/>
+        </p:nvSpPr>
+        <p:spPr>
+          <a:xfrm>
+            <a:off x="457200" y="182880"/>
+            <a:ext cx="11277295" cy="548640"/>
+          </a:xfrm>
+          <a:prstGeom prst="rect">
+            <a:avLst/>
+          </a:prstGeom>
+          <a:noFill/>
+        </p:spPr>
+        <p:txBody>
+          <a:bodyPr wrap="none">
+            <a:spAutoFit/>
+          </a:bodyPr>
+          <a:lstStyle/>
+          <a:p>
+            <a:r>
+              <a:rPr sz="3600" b="1">
+                <a:solidFill>
+                  <a:srgbClr val="1F4E79"/>
+                </a:solidFill>
+              </a:rPr>
+              <a:t>Core Idea</a:t>
+            </a:r>
+          </a:p>
+        </p:txBody>
+      </p:sp>
+      <p:sp>
+        <p:nvSpPr>
+          <p:cNvPr id="4" name="TextBox 3"/>
+          <p:cNvSpPr txBox="1"/>
+          <p:nvPr/>
+        </p:nvSpPr>
+        <p:spPr>
+          <a:xfrm>
+            <a:off x="822960" y="1188720"/>
+            <a:ext cx="10545775" cy="5029200"/>
+          </a:xfrm>
+          <a:prstGeom prst="rect">
+            <a:avLst/>
+          </a:prstGeom>
+          <a:noFill/>
+        </p:spPr>
+        <p:txBody>
+          <a:bodyPr wrap="none">
+            <a:spAutoFit/>
+          </a:bodyPr>
+          <a:lstStyle/>
+          <a:p>
+            <a:pPr>
+              <a:defRPr sz="2400"/>
+            </a:pPr>
+            <a:r>
+              <a:t>Add a custom instruction: kc</a:t>
+            </a:r>
+          </a:p>
+          <a:p>
+            <a:pPr>
+              <a:defRPr sz="2400"/>
+            </a:pPr>
+            <a:r>
+              <a:t>kc triggers a protected key check</a:t>
+            </a:r>
+          </a:p>
+          <a:p>
+            <a:pPr>
+              <a:defRPr sz="2400"/>
+            </a:pPr>
+            <a:r>
+              <a:t>A small FSM enables or blocks execution/debug</a:t>
+            </a:r>
+          </a:p>
+        </p:txBody>
+      </p:sp>
+    </p:spTree>
+  </p:cSld>
+  <p:clrMapOvr>
+    <a:masterClrMapping/>
+  </p:clrMapOvr>
+</p:sld>
+</file>
+
+<file path=ppt/slides/slide5.xml><?xml version="1.0" encoding="utf-8"?>
+<p:sld xmlns:a="http://schemas.openxmlformats.org/drawingml/2006/main" xmlns:p="http://schemas.openxmlformats.org/presentationml/2006/main" xmlns:r="http://schemas.openxmlformats.org/officeDocument/2006/relationships">
+  <p:cSld>
+    <p:spTree>
+      <p:nvGrpSpPr>
+        <p:cNvPr id="1" name=""/>
+        <p:cNvGrpSpPr/>
+        <p:nvPr/>
+      </p:nvGrpSpPr>
+      <p:grpSpPr/>
+      <p:sp>
+        <p:nvSpPr>
+          <p:cNvPr id="2" name="Title 1"/>
+          <p:cNvSpPr>
+            <a:spLocks noGrp="1"/>
+          </p:cNvSpPr>
+          <p:nvPr>
+            <p:ph type="title"/>
+          </p:nvPr>
+        </p:nvSpPr>
+        <p:spPr/>
+        <p:txBody>
+          <a:bodyPr/>
+          <a:lstStyle/>
+          <a:p/>
+        </p:txBody>
+      </p:sp>
+      <p:sp>
+        <p:nvSpPr>
+          <p:cNvPr id="3" name="TextBox 2"/>
+          <p:cNvSpPr txBox="1"/>
+          <p:nvPr/>
+        </p:nvSpPr>
+        <p:spPr>
+          <a:xfrm>
+            <a:off x="457200" y="182880"/>
+            <a:ext cx="11277295" cy="548640"/>
+          </a:xfrm>
+          <a:prstGeom prst="rect">
+            <a:avLst/>
+          </a:prstGeom>
+          <a:noFill/>
+        </p:spPr>
+        <p:txBody>
+          <a:bodyPr wrap="none">
+            <a:spAutoFit/>
+          </a:bodyPr>
+          <a:lstStyle/>
+          <a:p>
+            <a:r>
+              <a:rPr sz="3600" b="1">
+                <a:solidFill>
+                  <a:srgbClr val="1F4E79"/>
+                </a:solidFill>
+              </a:rPr>
+              <a:t>System Architecture</a:t>
+            </a:r>
+          </a:p>
+        </p:txBody>
+      </p:sp>
+      <p:pic>
+        <p:nvPicPr>
+          <p:cNvPr id="4" name="Picture 3" descr="fig_arch_flow.png"/>
+          <p:cNvPicPr>
+            <a:picLocks noChangeAspect="1"/>
+          </p:cNvPicPr>
+          <p:nvPr/>
+        </p:nvPicPr>
+        <p:blipFill>
+          <a:blip r:embed="rId2"/>
+          <a:stretch>
+            <a:fillRect/>
+          </a:stretch>
+        </p:blipFill>
+        <p:spPr>
+          <a:xfrm>
+            <a:off x="548640" y="1005840"/>
+            <a:ext cx="11094415" cy="6185105"/>
+          </a:xfrm>
+          <a:prstGeom prst="rect">
+            <a:avLst/>
+          </a:prstGeom>
+        </p:spPr>
+      </p:pic>
+    </p:spTree>
+  </p:cSld>
+  <p:clrMapOvr>
+    <a:masterClrMapping/>
+  </p:clrMapOvr>
+</p:sld>
+</file>
+
+<file path=ppt/slides/slide6.xml><?xml version="1.0" encoding="utf-8"?>
+<p:sld xmlns:a="http://schemas.openxmlformats.org/drawingml/2006/main" xmlns:p="http://schemas.openxmlformats.org/presentationml/2006/main" xmlns:r="http://schemas.openxmlformats.org/officeDocument/2006/relationships">
+  <p:cSld>
+    <p:spTree>
+      <p:nvGrpSpPr>
+        <p:cNvPr id="1" name=""/>
+        <p:cNvGrpSpPr/>
+        <p:nvPr/>
+      </p:nvGrpSpPr>
+      <p:grpSpPr/>
+      <p:sp>
+        <p:nvSpPr>
+          <p:cNvPr id="2" name="Title 1"/>
+          <p:cNvSpPr>
+            <a:spLocks noGrp="1"/>
+          </p:cNvSpPr>
+          <p:nvPr>
+            <p:ph type="title"/>
+          </p:nvPr>
+        </p:nvSpPr>
+        <p:spPr/>
+        <p:txBody>
+          <a:bodyPr/>
+          <a:lstStyle/>
+          <a:p/>
+        </p:txBody>
+      </p:sp>
+      <p:sp>
+        <p:nvSpPr>
+          <p:cNvPr id="3" name="TextBox 2"/>
+          <p:cNvSpPr txBox="1"/>
+          <p:nvPr/>
+        </p:nvSpPr>
+        <p:spPr>
+          <a:xfrm>
+            <a:off x="457200" y="182880"/>
+            <a:ext cx="11277295" cy="548640"/>
+          </a:xfrm>
+          <a:prstGeom prst="rect">
+            <a:avLst/>
+          </a:prstGeom>
+          <a:noFill/>
+        </p:spPr>
+        <p:txBody>
+          <a:bodyPr wrap="none">
+            <a:spAutoFit/>
+          </a:bodyPr>
+          <a:lstStyle/>
+          <a:p>
+            <a:r>
+              <a:rPr sz="3600" b="1">
+                <a:solidFill>
+                  <a:srgbClr val="1F4E79"/>
+                </a:solidFill>
+              </a:rPr>
+              <a:t>Authorization Steps</a:t>
+            </a:r>
+          </a:p>
+        </p:txBody>
+      </p:sp>
+      <p:sp>
+        <p:nvSpPr>
+          <p:cNvPr id="4" name="TextBox 3"/>
+          <p:cNvSpPr txBox="1"/>
+          <p:nvPr/>
+        </p:nvSpPr>
+        <p:spPr>
+          <a:xfrm>
+            <a:off x="822960" y="1188720"/>
+            <a:ext cx="10545775" cy="5029200"/>
+          </a:xfrm>
+          <a:prstGeom prst="rect">
+            <a:avLst/>
+          </a:prstGeom>
+          <a:noFill/>
+        </p:spPr>
+        <p:txBody>
+          <a:bodyPr wrap="none">
+            <a:spAutoFit/>
+          </a:bodyPr>
+          <a:lstStyle/>
+          <a:p>
+            <a:pPr>
+              <a:defRPr sz="2400"/>
+            </a:pPr>
+            <a:r>
+              <a:t>1) Start sequence from host</a:t>
+            </a:r>
+          </a:p>
+          <a:p>
+            <a:pPr>
+              <a:defRPr sz="2400"/>
+            </a:pPr>
+            <a:r>
+              <a:t>2) Send key parts</a:t>
+            </a:r>
+          </a:p>
+          <a:p>
+            <a:pPr>
+              <a:defRPr sz="2400"/>
+            </a:pPr>
+            <a:r>
+              <a:t>3) kc triggers device check</a:t>
+            </a:r>
+          </a:p>
+          <a:p>
+            <a:pPr>
+              <a:defRPr sz="2400"/>
+            </a:pPr>
+            <a:r>
+              <a:t>4) Match = enable, mismatch = halt</a:t>
+            </a:r>
+          </a:p>
+        </p:txBody>
+      </p:sp>
+    </p:spTree>
+  </p:cSld>
+  <p:clrMapOvr>
+    <a:masterClrMapping/>
+  </p:clrMapOvr>
+</p:sld>
+</file>
+
+<file path=ppt/slides/slide7.xml><?xml version="1.0" encoding="utf-8"?>
+<p:sld xmlns:a="http://schemas.openxmlformats.org/drawingml/2006/main" xmlns:p="http://schemas.openxmlformats.org/presentationml/2006/main" xmlns:r="http://schemas.openxmlformats.org/officeDocument/2006/relationships">
+  <p:cSld>
+    <p:spTree>
+      <p:nvGrpSpPr>
+        <p:cNvPr id="1" name=""/>
+        <p:cNvGrpSpPr/>
+        <p:nvPr/>
+      </p:nvGrpSpPr>
+      <p:grpSpPr/>
+      <p:sp>
+        <p:nvSpPr>
+          <p:cNvPr id="2" name="Title 1"/>
+          <p:cNvSpPr>
+            <a:spLocks noGrp="1"/>
+          </p:cNvSpPr>
+          <p:nvPr>
+            <p:ph type="title"/>
+          </p:nvPr>
+        </p:nvSpPr>
+        <p:spPr/>
+        <p:txBody>
+          <a:bodyPr/>
+          <a:lstStyle/>
+          <a:p/>
+        </p:txBody>
+      </p:sp>
+      <p:sp>
+        <p:nvSpPr>
+          <p:cNvPr id="3" name="TextBox 2"/>
+          <p:cNvSpPr txBox="1"/>
+          <p:nvPr/>
+        </p:nvSpPr>
+        <p:spPr>
+          <a:xfrm>
+            <a:off x="457200" y="182880"/>
+            <a:ext cx="11277295" cy="548640"/>
+          </a:xfrm>
+          <a:prstGeom prst="rect">
+            <a:avLst/>
+          </a:prstGeom>
+          <a:noFill/>
+        </p:spPr>
+        <p:txBody>
+          <a:bodyPr wrap="none">
+            <a:spAutoFit/>
+          </a:bodyPr>
+          <a:lstStyle/>
+          <a:p>
+            <a:r>
+              <a:rPr sz="3600" b="1">
+                <a:solidFill>
+                  <a:srgbClr val="1F4E79"/>
+                </a:solidFill>
+              </a:rPr>
+              <a:t>Toolchain Support</a:t>
+            </a:r>
+          </a:p>
+        </p:txBody>
+      </p:sp>
+      <p:sp>
+        <p:nvSpPr>
+          <p:cNvPr id="4" name="TextBox 3"/>
+          <p:cNvSpPr txBox="1"/>
+          <p:nvPr/>
+        </p:nvSpPr>
+        <p:spPr>
+          <a:xfrm>
+            <a:off x="822960" y="1188720"/>
+            <a:ext cx="10545775" cy="5029200"/>
+          </a:xfrm>
+          <a:prstGeom prst="rect">
+            <a:avLst/>
+          </a:prstGeom>
+          <a:noFill/>
+        </p:spPr>
+        <p:txBody>
+          <a:bodyPr wrap="none">
+            <a:spAutoFit/>
+          </a:bodyPr>
+          <a:lstStyle/>
+          <a:p>
+            <a:pPr>
+              <a:defRPr sz="2400"/>
+            </a:pPr>
+            <a:r>
+              <a:t>Custom GCC/binutils emit kc</a:t>
+            </a:r>
+          </a:p>
+          <a:p>
+            <a:pPr>
+              <a:defRPr sz="2400"/>
+            </a:pPr>
+            <a:r>
+              <a:t>Works with standard build flow</a:t>
+            </a:r>
+          </a:p>
+          <a:p>
+            <a:pPr>
+              <a:defRPr sz="2400"/>
+            </a:pPr>
+            <a:r>
+              <a:t>No manual binary patching</a:t>
+            </a:r>
+          </a:p>
+        </p:txBody>
+      </p:sp>
+    </p:spTree>
+  </p:cSld>
+  <p:clrMapOvr>
+    <a:masterClrMapping/>
+  </p:clrMapOvr>
+</p:sld>
+</file>
+
+<file path=ppt/slides/slide8.xml><?xml version="1.0" encoding="utf-8"?>
+<p:sld xmlns:a="http://schemas.openxmlformats.org/drawingml/2006/main" xmlns:p="http://schemas.openxmlformats.org/presentationml/2006/main" xmlns:r="http://schemas.openxmlformats.org/officeDocument/2006/relationships">
+  <p:cSld>
+    <p:spTree>
+      <p:nvGrpSpPr>
+        <p:cNvPr id="1" name=""/>
+        <p:cNvGrpSpPr/>
+        <p:nvPr/>
+      </p:nvGrpSpPr>
+      <p:grpSpPr/>
+      <p:sp>
+        <p:nvSpPr>
+          <p:cNvPr id="2" name="Title 1"/>
+          <p:cNvSpPr>
+            <a:spLocks noGrp="1"/>
+          </p:cNvSpPr>
+          <p:nvPr>
+            <p:ph type="title"/>
+          </p:nvPr>
+        </p:nvSpPr>
+        <p:spPr/>
+        <p:txBody>
+          <a:bodyPr/>
+          <a:lstStyle/>
+          <a:p/>
+        </p:txBody>
+      </p:sp>
+      <p:sp>
+        <p:nvSpPr>
+          <p:cNvPr id="3" name="TextBox 2"/>
+          <p:cNvSpPr txBox="1"/>
+          <p:nvPr/>
+        </p:nvSpPr>
+        <p:spPr>
+          <a:xfrm>
+            <a:off x="457200" y="182880"/>
+            <a:ext cx="11277295" cy="548640"/>
+          </a:xfrm>
+          <a:prstGeom prst="rect">
+            <a:avLst/>
+          </a:prstGeom>
+          <a:noFill/>
+        </p:spPr>
+        <p:txBody>
+          <a:bodyPr wrap="none">
+            <a:spAutoFit/>
+          </a:bodyPr>
+          <a:lstStyle/>
+          <a:p>
+            <a:r>
+              <a:rPr sz="3600" b="1">
+                <a:solidFill>
+                  <a:srgbClr val="1F4E79"/>
+                </a:solidFill>
+              </a:rPr>
+              <a:t>Host Workflow</a:t>
+            </a:r>
+          </a:p>
+        </p:txBody>
+      </p:sp>
+      <p:sp>
+        <p:nvSpPr>
+          <p:cNvPr id="4" name="TextBox 3"/>
+          <p:cNvSpPr txBox="1"/>
+          <p:nvPr/>
+        </p:nvSpPr>
+        <p:spPr>
+          <a:xfrm>
+            <a:off x="822960" y="1188720"/>
+            <a:ext cx="10545775" cy="5029200"/>
+          </a:xfrm>
+          <a:prstGeom prst="rect">
+            <a:avLst/>
+          </a:prstGeom>
+          <a:noFill/>
+        </p:spPr>
+        <p:txBody>
+          <a:bodyPr wrap="none">
+            <a:spAutoFit/>
+          </a:bodyPr>
+          <a:lstStyle/>
+          <a:p>
+            <a:pPr>
+              <a:defRPr sz="2400"/>
+            </a:pPr>
+            <a:r>
+              <a:t>Compile</a:t>
+            </a:r>
+          </a:p>
+          <a:p>
+            <a:pPr>
+              <a:defRPr sz="2400"/>
+            </a:pPr>
+            <a:r>
+              <a:t>Hex viewer</a:t>
+            </a:r>
+          </a:p>
+          <a:p>
+            <a:pPr>
+              <a:defRPr sz="2400"/>
+            </a:pPr>
+            <a:r>
+              <a:t>Key match</a:t>
+            </a:r>
+          </a:p>
+          <a:p>
+            <a:pPr>
+              <a:defRPr sz="2400"/>
+            </a:pPr>
+            <a:r>
+              <a:t>Connect and program</a:t>
+            </a:r>
+          </a:p>
+          <a:p>
+            <a:pPr>
+              <a:defRPr sz="2400"/>
+            </a:pPr>
+            <a:r>
+              <a:t>Logs for traceability</a:t>
+            </a:r>
+          </a:p>
+        </p:txBody>
+      </p:sp>
+    </p:spTree>
+  </p:cSld>
+  <p:clrMapOvr>
+    <a:masterClrMapping/>
+  </p:clrMapOvr>
+</p:sld>
+</file>
+
+<file path=ppt/slides/slide9.xml><?xml version="1.0" encoding="utf-8"?>
+<p:sld xmlns:a="http://schemas.openxmlformats.org/drawingml/2006/main" xmlns:p="http://schemas.openxmlformats.org/presentationml/2006/main" xmlns:r="http://schemas.openxmlformats.org/officeDocument/2006/relationships">
+  <p:cSld>
+    <p:spTree>
+      <p:nvGrpSpPr>
+        <p:cNvPr id="1" name=""/>
+        <p:cNvGrpSpPr/>
+        <p:nvPr/>
+      </p:nvGrpSpPr>
+      <p:grpSpPr/>
+      <p:sp>
+        <p:nvSpPr>
+          <p:cNvPr id="2" name="Title 1"/>
+          <p:cNvSpPr>
+            <a:spLocks noGrp="1"/>
+          </p:cNvSpPr>
+          <p:nvPr>
+            <p:ph type="title"/>
+          </p:nvPr>
+        </p:nvSpPr>
+        <p:spPr/>
+        <p:txBody>
+          <a:bodyPr/>
+          <a:lstStyle/>
+          <a:p/>
+        </p:txBody>
+      </p:sp>
+      <p:sp>
+        <p:nvSpPr>
+          <p:cNvPr id="3" name="TextBox 2"/>
+          <p:cNvSpPr txBox="1"/>
+          <p:nvPr/>
+        </p:nvSpPr>
+        <p:spPr>
+          <a:xfrm>
+            <a:off x="457200" y="182880"/>
+            <a:ext cx="11277295" cy="548640"/>
+          </a:xfrm>
+          <a:prstGeom prst="rect">
+            <a:avLst/>
+          </a:prstGeom>
+          <a:noFill/>
+        </p:spPr>
+        <p:txBody>
+          <a:bodyPr wrap="none">
+            <a:spAutoFit/>
+          </a:bodyPr>
+          <a:lstStyle/>
+          <a:p>
+            <a:r>
+              <a:rPr sz="3600" b="1">
+                <a:solidFill>
+                  <a:srgbClr val="1F4E79"/>
+                </a:solidFill>
+              </a:rPr>
+              <a:t>Results: Toolchain and Hex</a:t>
             </a:r>
           </a:p>
         </p:txBody>
@@ -3407,1684 +4448,6 @@
           </a:prstGeom>
         </p:spPr>
       </p:pic>
-    </p:spTree>
-  </p:cSld>
-  <p:clrMapOvr>
-    <a:masterClrMapping/>
-  </p:clrMapOvr>
-</p:sld>
-</file>
-
-<file path=ppt/slides/slide12.xml><?xml version="1.0" encoding="utf-8"?>
-<p:sld xmlns:a="http://schemas.openxmlformats.org/drawingml/2006/main" xmlns:p="http://schemas.openxmlformats.org/presentationml/2006/main" xmlns:r="http://schemas.openxmlformats.org/officeDocument/2006/relationships">
-  <p:cSld>
-    <p:spTree>
-      <p:nvGrpSpPr>
-        <p:cNvPr id="1" name=""/>
-        <p:cNvGrpSpPr/>
-        <p:nvPr/>
-      </p:nvGrpSpPr>
-      <p:grpSpPr/>
-      <p:sp>
-        <p:nvSpPr>
-          <p:cNvPr id="2" name="Title 1"/>
-          <p:cNvSpPr>
-            <a:spLocks noGrp="1"/>
-          </p:cNvSpPr>
-          <p:nvPr>
-            <p:ph type="title"/>
-          </p:nvPr>
-        </p:nvSpPr>
-        <p:spPr/>
-        <p:txBody>
-          <a:bodyPr/>
-          <a:lstStyle/>
-          <a:p/>
-        </p:txBody>
-      </p:sp>
-      <p:sp>
-        <p:nvSpPr>
-          <p:cNvPr id="3" name="TextBox 2"/>
-          <p:cNvSpPr txBox="1"/>
-          <p:nvPr/>
-        </p:nvSpPr>
-        <p:spPr>
-          <a:xfrm>
-            <a:off x="457200" y="182880"/>
-            <a:ext cx="11277295" cy="548640"/>
-          </a:xfrm>
-          <a:prstGeom prst="rect">
-            <a:avLst/>
-          </a:prstGeom>
-          <a:noFill/>
-        </p:spPr>
-        <p:txBody>
-          <a:bodyPr wrap="none">
-            <a:spAutoFit/>
-          </a:bodyPr>
-          <a:lstStyle/>
-          <a:p>
-            <a:r>
-              <a:rPr sz="3600" b="1">
-                <a:solidFill>
-                  <a:srgbClr val="1F4E79"/>
-                </a:solidFill>
-              </a:rPr>
-              <a:t>Results: Authorization and Debug Enablement</a:t>
-            </a:r>
-          </a:p>
-        </p:txBody>
-      </p:sp>
-      <p:pic>
-        <p:nvPicPr>
-          <p:cNvPr id="4" name="Picture 3" descr="fig_keymatch.png"/>
-          <p:cNvPicPr>
-            <a:picLocks noChangeAspect="1"/>
-          </p:cNvPicPr>
-          <p:nvPr/>
-        </p:nvPicPr>
-        <p:blipFill>
-          <a:blip r:embed="rId2"/>
-          <a:stretch>
-            <a:fillRect/>
-          </a:stretch>
-        </p:blipFill>
-        <p:spPr>
-          <a:xfrm>
-            <a:off x="640080" y="1005840"/>
-            <a:ext cx="10911535" cy="6583667"/>
-          </a:xfrm>
-          <a:prstGeom prst="rect">
-            <a:avLst/>
-          </a:prstGeom>
-        </p:spPr>
-      </p:pic>
-      <p:pic>
-        <p:nvPicPr>
-          <p:cNvPr id="5" name="Picture 4" descr="fig_debugenabled.png"/>
-          <p:cNvPicPr>
-            <a:picLocks noChangeAspect="1"/>
-          </p:cNvPicPr>
-          <p:nvPr/>
-        </p:nvPicPr>
-        <p:blipFill>
-          <a:blip r:embed="rId3"/>
-          <a:stretch>
-            <a:fillRect/>
-          </a:stretch>
-        </p:blipFill>
-        <p:spPr>
-          <a:xfrm>
-            <a:off x="640080" y="7818107"/>
-            <a:ext cx="10911535" cy="6600298"/>
-          </a:xfrm>
-          <a:prstGeom prst="rect">
-            <a:avLst/>
-          </a:prstGeom>
-        </p:spPr>
-      </p:pic>
-    </p:spTree>
-  </p:cSld>
-  <p:clrMapOvr>
-    <a:masterClrMapping/>
-  </p:clrMapOvr>
-</p:sld>
-</file>
-
-<file path=ppt/slides/slide13.xml><?xml version="1.0" encoding="utf-8"?>
-<p:sld xmlns:a="http://schemas.openxmlformats.org/drawingml/2006/main" xmlns:p="http://schemas.openxmlformats.org/presentationml/2006/main" xmlns:r="http://schemas.openxmlformats.org/officeDocument/2006/relationships">
-  <p:cSld>
-    <p:spTree>
-      <p:nvGrpSpPr>
-        <p:cNvPr id="1" name=""/>
-        <p:cNvGrpSpPr/>
-        <p:nvPr/>
-      </p:nvGrpSpPr>
-      <p:grpSpPr/>
-      <p:sp>
-        <p:nvSpPr>
-          <p:cNvPr id="2" name="Title 1"/>
-          <p:cNvSpPr>
-            <a:spLocks noGrp="1"/>
-          </p:cNvSpPr>
-          <p:nvPr>
-            <p:ph type="title"/>
-          </p:nvPr>
-        </p:nvSpPr>
-        <p:spPr/>
-        <p:txBody>
-          <a:bodyPr/>
-          <a:lstStyle/>
-          <a:p/>
-        </p:txBody>
-      </p:sp>
-      <p:sp>
-        <p:nvSpPr>
-          <p:cNvPr id="3" name="TextBox 2"/>
-          <p:cNvSpPr txBox="1"/>
-          <p:nvPr/>
-        </p:nvSpPr>
-        <p:spPr>
-          <a:xfrm>
-            <a:off x="457200" y="182880"/>
-            <a:ext cx="11277295" cy="548640"/>
-          </a:xfrm>
-          <a:prstGeom prst="rect">
-            <a:avLst/>
-          </a:prstGeom>
-          <a:noFill/>
-        </p:spPr>
-        <p:txBody>
-          <a:bodyPr wrap="none">
-            <a:spAutoFit/>
-          </a:bodyPr>
-          <a:lstStyle/>
-          <a:p>
-            <a:r>
-              <a:rPr sz="3600" b="1">
-                <a:solidFill>
-                  <a:srgbClr val="1F4E79"/>
-                </a:solidFill>
-              </a:rPr>
-              <a:t>Results: Programming Workflow</a:t>
-            </a:r>
-          </a:p>
-        </p:txBody>
-      </p:sp>
-      <p:pic>
-        <p:nvPicPr>
-          <p:cNvPr id="4" name="Picture 3" descr="fig_connected.png"/>
-          <p:cNvPicPr>
-            <a:picLocks noChangeAspect="1"/>
-          </p:cNvPicPr>
-          <p:nvPr/>
-        </p:nvPicPr>
-        <p:blipFill>
-          <a:blip r:embed="rId2"/>
-          <a:stretch>
-            <a:fillRect/>
-          </a:stretch>
-        </p:blipFill>
-        <p:spPr>
-          <a:xfrm>
-            <a:off x="640080" y="1005840"/>
-            <a:ext cx="10911535" cy="7137749"/>
-          </a:xfrm>
-          <a:prstGeom prst="rect">
-            <a:avLst/>
-          </a:prstGeom>
-        </p:spPr>
-      </p:pic>
-      <p:pic>
-        <p:nvPicPr>
-          <p:cNvPr id="5" name="Picture 4" descr="fig_loadimage.png"/>
-          <p:cNvPicPr>
-            <a:picLocks noChangeAspect="1"/>
-          </p:cNvPicPr>
-          <p:nvPr/>
-        </p:nvPicPr>
-        <p:blipFill>
-          <a:blip r:embed="rId3"/>
-          <a:stretch>
-            <a:fillRect/>
-          </a:stretch>
-        </p:blipFill>
-        <p:spPr>
-          <a:xfrm>
-            <a:off x="640080" y="8372189"/>
-            <a:ext cx="10911535" cy="4971788"/>
-          </a:xfrm>
-          <a:prstGeom prst="rect">
-            <a:avLst/>
-          </a:prstGeom>
-        </p:spPr>
-      </p:pic>
-    </p:spTree>
-  </p:cSld>
-  <p:clrMapOvr>
-    <a:masterClrMapping/>
-  </p:clrMapOvr>
-</p:sld>
-</file>
-
-<file path=ppt/slides/slide14.xml><?xml version="1.0" encoding="utf-8"?>
-<p:sld xmlns:a="http://schemas.openxmlformats.org/drawingml/2006/main" xmlns:p="http://schemas.openxmlformats.org/presentationml/2006/main" xmlns:r="http://schemas.openxmlformats.org/officeDocument/2006/relationships">
-  <p:cSld>
-    <p:spTree>
-      <p:nvGrpSpPr>
-        <p:cNvPr id="1" name=""/>
-        <p:cNvGrpSpPr/>
-        <p:nvPr/>
-      </p:nvGrpSpPr>
-      <p:grpSpPr/>
-      <p:sp>
-        <p:nvSpPr>
-          <p:cNvPr id="2" name="Title 1"/>
-          <p:cNvSpPr>
-            <a:spLocks noGrp="1"/>
-          </p:cNvSpPr>
-          <p:nvPr>
-            <p:ph type="title"/>
-          </p:nvPr>
-        </p:nvSpPr>
-        <p:spPr/>
-        <p:txBody>
-          <a:bodyPr/>
-          <a:lstStyle/>
-          <a:p/>
-        </p:txBody>
-      </p:sp>
-      <p:sp>
-        <p:nvSpPr>
-          <p:cNvPr id="3" name="TextBox 2"/>
-          <p:cNvSpPr txBox="1"/>
-          <p:nvPr/>
-        </p:nvSpPr>
-        <p:spPr>
-          <a:xfrm>
-            <a:off x="457200" y="182880"/>
-            <a:ext cx="11277295" cy="548640"/>
-          </a:xfrm>
-          <a:prstGeom prst="rect">
-            <a:avLst/>
-          </a:prstGeom>
-          <a:noFill/>
-        </p:spPr>
-        <p:txBody>
-          <a:bodyPr wrap="none">
-            <a:spAutoFit/>
-          </a:bodyPr>
-          <a:lstStyle/>
-          <a:p>
-            <a:r>
-              <a:rPr sz="3600" b="1">
-                <a:solidFill>
-                  <a:srgbClr val="1F4E79"/>
-                </a:solidFill>
-              </a:rPr>
-              <a:t>Discussion</a:t>
-            </a:r>
-          </a:p>
-        </p:txBody>
-      </p:sp>
-      <p:sp>
-        <p:nvSpPr>
-          <p:cNvPr id="4" name="TextBox 3"/>
-          <p:cNvSpPr txBox="1"/>
-          <p:nvPr/>
-        </p:nvSpPr>
-        <p:spPr>
-          <a:xfrm>
-            <a:off x="822960" y="1188720"/>
-            <a:ext cx="10545775" cy="5029200"/>
-          </a:xfrm>
-          <a:prstGeom prst="rect">
-            <a:avLst/>
-          </a:prstGeom>
-          <a:noFill/>
-        </p:spPr>
-        <p:txBody>
-          <a:bodyPr wrap="none">
-            <a:spAutoFit/>
-          </a:bodyPr>
-          <a:lstStyle/>
-          <a:p>
-            <a:pPr>
-              <a:defRPr sz="2200"/>
-            </a:pPr>
-            <a:r>
-              <a:t>Authorization enforced at the device, not only at the host</a:t>
-            </a:r>
-          </a:p>
-          <a:p>
-            <a:pPr>
-              <a:defRPr sz="2200"/>
-            </a:pPr>
-            <a:r>
-              <a:t>Debug enablement released only after explicit authorization</a:t>
-            </a:r>
-          </a:p>
-          <a:p>
-            <a:pPr>
-              <a:defRPr sz="2200"/>
-            </a:pPr>
-            <a:r>
-              <a:t>Fail-stop behavior limits repeated probing in a single boot</a:t>
-            </a:r>
-          </a:p>
-          <a:p>
-            <a:pPr>
-              <a:defRPr sz="2200"/>
-            </a:pPr>
-            <a:r>
-              <a:t>Toolchain and provisioning are part of the trusted computing base</a:t>
-            </a:r>
-          </a:p>
-        </p:txBody>
-      </p:sp>
-    </p:spTree>
-  </p:cSld>
-  <p:clrMapOvr>
-    <a:masterClrMapping/>
-  </p:clrMapOvr>
-</p:sld>
-</file>
-
-<file path=ppt/slides/slide15.xml><?xml version="1.0" encoding="utf-8"?>
-<p:sld xmlns:a="http://schemas.openxmlformats.org/drawingml/2006/main" xmlns:p="http://schemas.openxmlformats.org/presentationml/2006/main" xmlns:r="http://schemas.openxmlformats.org/officeDocument/2006/relationships">
-  <p:cSld>
-    <p:spTree>
-      <p:nvGrpSpPr>
-        <p:cNvPr id="1" name=""/>
-        <p:cNvGrpSpPr/>
-        <p:nvPr/>
-      </p:nvGrpSpPr>
-      <p:grpSpPr/>
-      <p:sp>
-        <p:nvSpPr>
-          <p:cNvPr id="2" name="Title 1"/>
-          <p:cNvSpPr>
-            <a:spLocks noGrp="1"/>
-          </p:cNvSpPr>
-          <p:nvPr>
-            <p:ph type="title"/>
-          </p:nvPr>
-        </p:nvSpPr>
-        <p:spPr/>
-        <p:txBody>
-          <a:bodyPr/>
-          <a:lstStyle/>
-          <a:p/>
-        </p:txBody>
-      </p:sp>
-      <p:sp>
-        <p:nvSpPr>
-          <p:cNvPr id="3" name="TextBox 2"/>
-          <p:cNvSpPr txBox="1"/>
-          <p:nvPr/>
-        </p:nvSpPr>
-        <p:spPr>
-          <a:xfrm>
-            <a:off x="457200" y="182880"/>
-            <a:ext cx="11277295" cy="548640"/>
-          </a:xfrm>
-          <a:prstGeom prst="rect">
-            <a:avLst/>
-          </a:prstGeom>
-          <a:noFill/>
-        </p:spPr>
-        <p:txBody>
-          <a:bodyPr wrap="none">
-            <a:spAutoFit/>
-          </a:bodyPr>
-          <a:lstStyle/>
-          <a:p>
-            <a:r>
-              <a:rPr sz="3600" b="1">
-                <a:solidFill>
-                  <a:srgbClr val="1F4E79"/>
-                </a:solidFill>
-              </a:rPr>
-              <a:t>Conclusion</a:t>
-            </a:r>
-          </a:p>
-        </p:txBody>
-      </p:sp>
-      <p:sp>
-        <p:nvSpPr>
-          <p:cNvPr id="4" name="TextBox 3"/>
-          <p:cNvSpPr txBox="1"/>
-          <p:nvPr/>
-        </p:nvSpPr>
-        <p:spPr>
-          <a:xfrm>
-            <a:off x="822960" y="1188720"/>
-            <a:ext cx="10545775" cy="5029200"/>
-          </a:xfrm>
-          <a:prstGeom prst="rect">
-            <a:avLst/>
-          </a:prstGeom>
-          <a:noFill/>
-        </p:spPr>
-        <p:txBody>
-          <a:bodyPr wrap="none">
-            <a:spAutoFit/>
-          </a:bodyPr>
-          <a:lstStyle/>
-          <a:p>
-            <a:pPr>
-              <a:defRPr sz="2200"/>
-            </a:pPr>
-            <a:r>
-              <a:t>Introduced instruction-triggered, key-gated authorization</a:t>
-            </a:r>
-          </a:p>
-          <a:p>
-            <a:pPr>
-              <a:defRPr sz="2200"/>
-            </a:pPr>
-            <a:r>
-              <a:t>Protected key storage and verification datapath enforce access control</a:t>
-            </a:r>
-          </a:p>
-          <a:p>
-            <a:pPr>
-              <a:defRPr sz="2200"/>
-            </a:pPr>
-            <a:r>
-              <a:t>End-to-end toolchain support enables deployable security</a:t>
-            </a:r>
-          </a:p>
-          <a:p>
-            <a:pPr>
-              <a:defRPr sz="2200"/>
-            </a:pPr>
-            <a:r>
-              <a:t>Evidence demonstrates feasibility and policy enforcement</a:t>
-            </a:r>
-          </a:p>
-        </p:txBody>
-      </p:sp>
-    </p:spTree>
-  </p:cSld>
-  <p:clrMapOvr>
-    <a:masterClrMapping/>
-  </p:clrMapOvr>
-</p:sld>
-</file>
-
-<file path=ppt/slides/slide16.xml><?xml version="1.0" encoding="utf-8"?>
-<p:sld xmlns:a="http://schemas.openxmlformats.org/drawingml/2006/main" xmlns:p="http://schemas.openxmlformats.org/presentationml/2006/main" xmlns:r="http://schemas.openxmlformats.org/officeDocument/2006/relationships">
-  <p:cSld>
-    <p:spTree>
-      <p:nvGrpSpPr>
-        <p:cNvPr id="1" name=""/>
-        <p:cNvGrpSpPr/>
-        <p:nvPr/>
-      </p:nvGrpSpPr>
-      <p:grpSpPr/>
-      <p:sp>
-        <p:nvSpPr>
-          <p:cNvPr id="2" name="Title 1"/>
-          <p:cNvSpPr>
-            <a:spLocks noGrp="1"/>
-          </p:cNvSpPr>
-          <p:nvPr>
-            <p:ph type="title"/>
-          </p:nvPr>
-        </p:nvSpPr>
-        <p:spPr/>
-        <p:txBody>
-          <a:bodyPr/>
-          <a:lstStyle/>
-          <a:p/>
-        </p:txBody>
-      </p:sp>
-      <p:sp>
-        <p:nvSpPr>
-          <p:cNvPr id="3" name="TextBox 2"/>
-          <p:cNvSpPr txBox="1"/>
-          <p:nvPr/>
-        </p:nvSpPr>
-        <p:spPr>
-          <a:xfrm>
-            <a:off x="457200" y="182880"/>
-            <a:ext cx="11277295" cy="548640"/>
-          </a:xfrm>
-          <a:prstGeom prst="rect">
-            <a:avLst/>
-          </a:prstGeom>
-          <a:noFill/>
-        </p:spPr>
-        <p:txBody>
-          <a:bodyPr wrap="none">
-            <a:spAutoFit/>
-          </a:bodyPr>
-          <a:lstStyle/>
-          <a:p>
-            <a:r>
-              <a:rPr sz="3600" b="1">
-                <a:solidFill>
-                  <a:srgbClr val="1F4E79"/>
-                </a:solidFill>
-              </a:rPr>
-              <a:t>Future Work</a:t>
-            </a:r>
-          </a:p>
-        </p:txBody>
-      </p:sp>
-      <p:sp>
-        <p:nvSpPr>
-          <p:cNvPr id="4" name="TextBox 3"/>
-          <p:cNvSpPr txBox="1"/>
-          <p:nvPr/>
-        </p:nvSpPr>
-        <p:spPr>
-          <a:xfrm>
-            <a:off x="822960" y="1188720"/>
-            <a:ext cx="10545775" cy="5029200"/>
-          </a:xfrm>
-          <a:prstGeom prst="rect">
-            <a:avLst/>
-          </a:prstGeom>
-          <a:noFill/>
-        </p:spPr>
-        <p:txBody>
-          <a:bodyPr wrap="none">
-            <a:spAutoFit/>
-          </a:bodyPr>
-          <a:lstStyle/>
-          <a:p>
-            <a:pPr>
-              <a:defRPr sz="2200"/>
-            </a:pPr>
-            <a:r>
-              <a:t>Formalize boot-chain policy for BootROM placement across platforms</a:t>
-            </a:r>
-          </a:p>
-          <a:p>
-            <a:pPr>
-              <a:defRPr sz="2200"/>
-            </a:pPr>
-            <a:r>
-              <a:t>Add key rotation, revocation, and per-firmware authorization records</a:t>
-            </a:r>
-          </a:p>
-          <a:p>
-            <a:pPr>
-              <a:defRPr sz="2200"/>
-            </a:pPr>
-            <a:r>
-              <a:t>Evaluate fault/glitch resilience and side-channel leakage</a:t>
-            </a:r>
-          </a:p>
-          <a:p>
-            <a:pPr>
-              <a:defRPr sz="2200"/>
-            </a:pPr>
-            <a:r>
-              <a:t>Quantify area/power/latency and expand regression testing</a:t>
-            </a:r>
-          </a:p>
-        </p:txBody>
-      </p:sp>
-    </p:spTree>
-  </p:cSld>
-  <p:clrMapOvr>
-    <a:masterClrMapping/>
-  </p:clrMapOvr>
-</p:sld>
-</file>
-
-<file path=ppt/slides/slide17.xml><?xml version="1.0" encoding="utf-8"?>
-<p:sld xmlns:a="http://schemas.openxmlformats.org/drawingml/2006/main" xmlns:p="http://schemas.openxmlformats.org/presentationml/2006/main" xmlns:r="http://schemas.openxmlformats.org/officeDocument/2006/relationships">
-  <p:cSld>
-    <p:spTree>
-      <p:nvGrpSpPr>
-        <p:cNvPr id="1" name=""/>
-        <p:cNvGrpSpPr/>
-        <p:nvPr/>
-      </p:nvGrpSpPr>
-      <p:grpSpPr/>
-      <p:sp>
-        <p:nvSpPr>
-          <p:cNvPr id="2" name="Title 1"/>
-          <p:cNvSpPr>
-            <a:spLocks noGrp="1"/>
-          </p:cNvSpPr>
-          <p:nvPr>
-            <p:ph type="title"/>
-          </p:nvPr>
-        </p:nvSpPr>
-        <p:spPr/>
-        <p:txBody>
-          <a:bodyPr/>
-          <a:lstStyle/>
-          <a:p/>
-        </p:txBody>
-      </p:sp>
-      <p:sp>
-        <p:nvSpPr>
-          <p:cNvPr id="3" name="TextBox 2"/>
-          <p:cNvSpPr txBox="1"/>
-          <p:nvPr/>
-        </p:nvSpPr>
-        <p:spPr>
-          <a:xfrm>
-            <a:off x="457200" y="182880"/>
-            <a:ext cx="11277295" cy="548640"/>
-          </a:xfrm>
-          <a:prstGeom prst="rect">
-            <a:avLst/>
-          </a:prstGeom>
-          <a:noFill/>
-        </p:spPr>
-        <p:txBody>
-          <a:bodyPr wrap="none">
-            <a:spAutoFit/>
-          </a:bodyPr>
-          <a:lstStyle/>
-          <a:p>
-            <a:r>
-              <a:rPr sz="3600" b="1">
-                <a:solidFill>
-                  <a:srgbClr val="1F4E79"/>
-                </a:solidFill>
-              </a:rPr>
-              <a:t>Questions?</a:t>
-            </a:r>
-          </a:p>
-        </p:txBody>
-      </p:sp>
-    </p:spTree>
-  </p:cSld>
-  <p:clrMapOvr>
-    <a:masterClrMapping/>
-  </p:clrMapOvr>
-</p:sld>
-</file>
-
-<file path=ppt/slides/slide2.xml><?xml version="1.0" encoding="utf-8"?>
-<p:sld xmlns:a="http://schemas.openxmlformats.org/drawingml/2006/main" xmlns:p="http://schemas.openxmlformats.org/presentationml/2006/main" xmlns:r="http://schemas.openxmlformats.org/officeDocument/2006/relationships">
-  <p:cSld>
-    <p:spTree>
-      <p:nvGrpSpPr>
-        <p:cNvPr id="1" name=""/>
-        <p:cNvGrpSpPr/>
-        <p:nvPr/>
-      </p:nvGrpSpPr>
-      <p:grpSpPr/>
-      <p:sp>
-        <p:nvSpPr>
-          <p:cNvPr id="2" name="Title 1"/>
-          <p:cNvSpPr>
-            <a:spLocks noGrp="1"/>
-          </p:cNvSpPr>
-          <p:nvPr>
-            <p:ph type="title"/>
-          </p:nvPr>
-        </p:nvSpPr>
-        <p:spPr/>
-        <p:txBody>
-          <a:bodyPr/>
-          <a:lstStyle/>
-          <a:p/>
-        </p:txBody>
-      </p:sp>
-      <p:sp>
-        <p:nvSpPr>
-          <p:cNvPr id="3" name="TextBox 2"/>
-          <p:cNvSpPr txBox="1"/>
-          <p:nvPr/>
-        </p:nvSpPr>
-        <p:spPr>
-          <a:xfrm>
-            <a:off x="457200" y="182880"/>
-            <a:ext cx="11277295" cy="548640"/>
-          </a:xfrm>
-          <a:prstGeom prst="rect">
-            <a:avLst/>
-          </a:prstGeom>
-          <a:noFill/>
-        </p:spPr>
-        <p:txBody>
-          <a:bodyPr wrap="none">
-            <a:spAutoFit/>
-          </a:bodyPr>
-          <a:lstStyle/>
-          <a:p>
-            <a:r>
-              <a:rPr sz="3600" b="1">
-                <a:solidFill>
-                  <a:srgbClr val="1F4E79"/>
-                </a:solidFill>
-              </a:rPr>
-              <a:t>Agenda</a:t>
-            </a:r>
-          </a:p>
-        </p:txBody>
-      </p:sp>
-      <p:sp>
-        <p:nvSpPr>
-          <p:cNvPr id="4" name="TextBox 3"/>
-          <p:cNvSpPr txBox="1"/>
-          <p:nvPr/>
-        </p:nvSpPr>
-        <p:spPr>
-          <a:xfrm>
-            <a:off x="822960" y="1188720"/>
-            <a:ext cx="10545775" cy="5029200"/>
-          </a:xfrm>
-          <a:prstGeom prst="rect">
-            <a:avLst/>
-          </a:prstGeom>
-          <a:noFill/>
-        </p:spPr>
-        <p:txBody>
-          <a:bodyPr wrap="none">
-            <a:spAutoFit/>
-          </a:bodyPr>
-          <a:lstStyle/>
-          <a:p>
-            <a:pPr>
-              <a:defRPr sz="2200"/>
-            </a:pPr>
-            <a:r>
-              <a:t>Motivation and problem statement</a:t>
-            </a:r>
-          </a:p>
-          <a:p>
-            <a:pPr>
-              <a:defRPr sz="2200"/>
-            </a:pPr>
-            <a:r>
-              <a:t>Proposed architecture</a:t>
-            </a:r>
-          </a:p>
-          <a:p>
-            <a:pPr>
-              <a:defRPr sz="2200"/>
-            </a:pPr>
-            <a:r>
-              <a:t>ISA extension and authorization flow</a:t>
-            </a:r>
-          </a:p>
-          <a:p>
-            <a:pPr>
-              <a:defRPr sz="2200"/>
-            </a:pPr>
-            <a:r>
-              <a:t>Implementation and toolchain integration</a:t>
-            </a:r>
-          </a:p>
-          <a:p>
-            <a:pPr>
-              <a:defRPr sz="2200"/>
-            </a:pPr>
-            <a:r>
-              <a:t>Evaluation and results</a:t>
-            </a:r>
-          </a:p>
-          <a:p>
-            <a:pPr>
-              <a:defRPr sz="2200"/>
-            </a:pPr>
-            <a:r>
-              <a:t>Discussion and conclusion</a:t>
-            </a:r>
-          </a:p>
-        </p:txBody>
-      </p:sp>
-    </p:spTree>
-  </p:cSld>
-  <p:clrMapOvr>
-    <a:masterClrMapping/>
-  </p:clrMapOvr>
-</p:sld>
-</file>
-
-<file path=ppt/slides/slide3.xml><?xml version="1.0" encoding="utf-8"?>
-<p:sld xmlns:a="http://schemas.openxmlformats.org/drawingml/2006/main" xmlns:p="http://schemas.openxmlformats.org/presentationml/2006/main" xmlns:r="http://schemas.openxmlformats.org/officeDocument/2006/relationships">
-  <p:cSld>
-    <p:spTree>
-      <p:nvGrpSpPr>
-        <p:cNvPr id="1" name=""/>
-        <p:cNvGrpSpPr/>
-        <p:nvPr/>
-      </p:nvGrpSpPr>
-      <p:grpSpPr/>
-      <p:sp>
-        <p:nvSpPr>
-          <p:cNvPr id="2" name="Title 1"/>
-          <p:cNvSpPr>
-            <a:spLocks noGrp="1"/>
-          </p:cNvSpPr>
-          <p:nvPr>
-            <p:ph type="title"/>
-          </p:nvPr>
-        </p:nvSpPr>
-        <p:spPr/>
-        <p:txBody>
-          <a:bodyPr/>
-          <a:lstStyle/>
-          <a:p/>
-        </p:txBody>
-      </p:sp>
-      <p:sp>
-        <p:nvSpPr>
-          <p:cNvPr id="3" name="TextBox 2"/>
-          <p:cNvSpPr txBox="1"/>
-          <p:nvPr/>
-        </p:nvSpPr>
-        <p:spPr>
-          <a:xfrm>
-            <a:off x="457200" y="182880"/>
-            <a:ext cx="11277295" cy="548640"/>
-          </a:xfrm>
-          <a:prstGeom prst="rect">
-            <a:avLst/>
-          </a:prstGeom>
-          <a:noFill/>
-        </p:spPr>
-        <p:txBody>
-          <a:bodyPr wrap="none">
-            <a:spAutoFit/>
-          </a:bodyPr>
-          <a:lstStyle/>
-          <a:p>
-            <a:r>
-              <a:rPr sz="3600" b="1">
-                <a:solidFill>
-                  <a:srgbClr val="1F4E79"/>
-                </a:solidFill>
-              </a:rPr>
-              <a:t>Motivation and Threat Model</a:t>
-            </a:r>
-          </a:p>
-        </p:txBody>
-      </p:sp>
-      <p:sp>
-        <p:nvSpPr>
-          <p:cNvPr id="4" name="TextBox 3"/>
-          <p:cNvSpPr txBox="1"/>
-          <p:nvPr/>
-        </p:nvSpPr>
-        <p:spPr>
-          <a:xfrm>
-            <a:off x="822960" y="1188720"/>
-            <a:ext cx="10545775" cy="5029200"/>
-          </a:xfrm>
-          <a:prstGeom prst="rect">
-            <a:avLst/>
-          </a:prstGeom>
-          <a:noFill/>
-        </p:spPr>
-        <p:txBody>
-          <a:bodyPr wrap="none">
-            <a:spAutoFit/>
-          </a:bodyPr>
-          <a:lstStyle/>
-          <a:p>
-            <a:pPr>
-              <a:defRPr sz="2200"/>
-            </a:pPr>
-            <a:r>
-              <a:t>Physical access enables firmware replacement and invasive debugging</a:t>
-            </a:r>
-          </a:p>
-          <a:p>
-            <a:pPr>
-              <a:defRPr sz="2200"/>
-            </a:pPr>
-            <a:r>
-              <a:t>Secure boot authenticates the initial image but not post-boot debug/programming</a:t>
-            </a:r>
-          </a:p>
-          <a:p>
-            <a:pPr>
-              <a:defRPr sz="2200"/>
-            </a:pPr>
-            <a:r>
-              <a:t>Debug interfaces expose memory and execution control</a:t>
-            </a:r>
-          </a:p>
-          <a:p>
-            <a:pPr>
-              <a:defRPr sz="2200"/>
-            </a:pPr>
-            <a:r>
-              <a:t>Need device-local authorization for execution and debug enablement</a:t>
-            </a:r>
-          </a:p>
-        </p:txBody>
-      </p:sp>
-    </p:spTree>
-  </p:cSld>
-  <p:clrMapOvr>
-    <a:masterClrMapping/>
-  </p:clrMapOvr>
-</p:sld>
-</file>
-
-<file path=ppt/slides/slide4.xml><?xml version="1.0" encoding="utf-8"?>
-<p:sld xmlns:a="http://schemas.openxmlformats.org/drawingml/2006/main" xmlns:p="http://schemas.openxmlformats.org/presentationml/2006/main" xmlns:r="http://schemas.openxmlformats.org/officeDocument/2006/relationships">
-  <p:cSld>
-    <p:spTree>
-      <p:nvGrpSpPr>
-        <p:cNvPr id="1" name=""/>
-        <p:cNvGrpSpPr/>
-        <p:nvPr/>
-      </p:nvGrpSpPr>
-      <p:grpSpPr/>
-      <p:sp>
-        <p:nvSpPr>
-          <p:cNvPr id="2" name="Title 1"/>
-          <p:cNvSpPr>
-            <a:spLocks noGrp="1"/>
-          </p:cNvSpPr>
-          <p:nvPr>
-            <p:ph type="title"/>
-          </p:nvPr>
-        </p:nvSpPr>
-        <p:spPr/>
-        <p:txBody>
-          <a:bodyPr/>
-          <a:lstStyle/>
-          <a:p/>
-        </p:txBody>
-      </p:sp>
-      <p:sp>
-        <p:nvSpPr>
-          <p:cNvPr id="3" name="TextBox 2"/>
-          <p:cNvSpPr txBox="1"/>
-          <p:nvPr/>
-        </p:nvSpPr>
-        <p:spPr>
-          <a:xfrm>
-            <a:off x="457200" y="182880"/>
-            <a:ext cx="11277295" cy="548640"/>
-          </a:xfrm>
-          <a:prstGeom prst="rect">
-            <a:avLst/>
-          </a:prstGeom>
-          <a:noFill/>
-        </p:spPr>
-        <p:txBody>
-          <a:bodyPr wrap="none">
-            <a:spAutoFit/>
-          </a:bodyPr>
-          <a:lstStyle/>
-          <a:p>
-            <a:r>
-              <a:rPr sz="3600" b="1">
-                <a:solidFill>
-                  <a:srgbClr val="1F4E79"/>
-                </a:solidFill>
-              </a:rPr>
-              <a:t>Design Goals</a:t>
-            </a:r>
-          </a:p>
-        </p:txBody>
-      </p:sp>
-      <p:sp>
-        <p:nvSpPr>
-          <p:cNvPr id="4" name="TextBox 3"/>
-          <p:cNvSpPr txBox="1"/>
-          <p:nvPr/>
-        </p:nvSpPr>
-        <p:spPr>
-          <a:xfrm>
-            <a:off x="822960" y="1188720"/>
-            <a:ext cx="10545775" cy="5029200"/>
-          </a:xfrm>
-          <a:prstGeom prst="rect">
-            <a:avLst/>
-          </a:prstGeom>
-          <a:noFill/>
-        </p:spPr>
-        <p:txBody>
-          <a:bodyPr wrap="none">
-            <a:spAutoFit/>
-          </a:bodyPr>
-          <a:lstStyle/>
-          <a:p>
-            <a:pPr>
-              <a:defRPr sz="2200"/>
-            </a:pPr>
-            <a:r>
-              <a:t>Gate execution and debug enablement on-device</a:t>
-            </a:r>
-          </a:p>
-          <a:p>
-            <a:pPr>
-              <a:defRPr sz="2200"/>
-            </a:pPr>
-            <a:r>
-              <a:t>Keep key material out of the normal load/store path</a:t>
-            </a:r>
-          </a:p>
-          <a:p>
-            <a:pPr>
-              <a:defRPr sz="2200"/>
-            </a:pPr>
-            <a:r>
-              <a:t>Integrate with compiler and toolchain for reproducible binaries</a:t>
-            </a:r>
-          </a:p>
-          <a:p>
-            <a:pPr>
-              <a:defRPr sz="2200"/>
-            </a:pPr>
-            <a:r>
-              <a:t>Provide traceability via host-device binding and audit logs</a:t>
-            </a:r>
-          </a:p>
-        </p:txBody>
-      </p:sp>
-    </p:spTree>
-  </p:cSld>
-  <p:clrMapOvr>
-    <a:masterClrMapping/>
-  </p:clrMapOvr>
-</p:sld>
-</file>
-
-<file path=ppt/slides/slide5.xml><?xml version="1.0" encoding="utf-8"?>
-<p:sld xmlns:a="http://schemas.openxmlformats.org/drawingml/2006/main" xmlns:p="http://schemas.openxmlformats.org/presentationml/2006/main" xmlns:r="http://schemas.openxmlformats.org/officeDocument/2006/relationships">
-  <p:cSld>
-    <p:spTree>
-      <p:nvGrpSpPr>
-        <p:cNvPr id="1" name=""/>
-        <p:cNvGrpSpPr/>
-        <p:nvPr/>
-      </p:nvGrpSpPr>
-      <p:grpSpPr/>
-      <p:sp>
-        <p:nvSpPr>
-          <p:cNvPr id="2" name="Title 1"/>
-          <p:cNvSpPr>
-            <a:spLocks noGrp="1"/>
-          </p:cNvSpPr>
-          <p:nvPr>
-            <p:ph type="title"/>
-          </p:nvPr>
-        </p:nvSpPr>
-        <p:spPr/>
-        <p:txBody>
-          <a:bodyPr/>
-          <a:lstStyle/>
-          <a:p/>
-        </p:txBody>
-      </p:sp>
-      <p:sp>
-        <p:nvSpPr>
-          <p:cNvPr id="3" name="TextBox 2"/>
-          <p:cNvSpPr txBox="1"/>
-          <p:nvPr/>
-        </p:nvSpPr>
-        <p:spPr>
-          <a:xfrm>
-            <a:off x="457200" y="182880"/>
-            <a:ext cx="11277295" cy="548640"/>
-          </a:xfrm>
-          <a:prstGeom prst="rect">
-            <a:avLst/>
-          </a:prstGeom>
-          <a:noFill/>
-        </p:spPr>
-        <p:txBody>
-          <a:bodyPr wrap="none">
-            <a:spAutoFit/>
-          </a:bodyPr>
-          <a:lstStyle/>
-          <a:p>
-            <a:r>
-              <a:rPr sz="3600" b="1">
-                <a:solidFill>
-                  <a:srgbClr val="1F4E79"/>
-                </a:solidFill>
-              </a:rPr>
-              <a:t>System Architecture Overview</a:t>
-            </a:r>
-          </a:p>
-        </p:txBody>
-      </p:sp>
-      <p:pic>
-        <p:nvPicPr>
-          <p:cNvPr id="4" name="Picture 3" descr="fig_arch_flow.png"/>
-          <p:cNvPicPr>
-            <a:picLocks noChangeAspect="1"/>
-          </p:cNvPicPr>
-          <p:nvPr/>
-        </p:nvPicPr>
-        <p:blipFill>
-          <a:blip r:embed="rId2"/>
-          <a:stretch>
-            <a:fillRect/>
-          </a:stretch>
-        </p:blipFill>
-        <p:spPr>
-          <a:xfrm>
-            <a:off x="548640" y="1005840"/>
-            <a:ext cx="11094415" cy="6185105"/>
-          </a:xfrm>
-          <a:prstGeom prst="rect">
-            <a:avLst/>
-          </a:prstGeom>
-        </p:spPr>
-      </p:pic>
-    </p:spTree>
-  </p:cSld>
-  <p:clrMapOvr>
-    <a:masterClrMapping/>
-  </p:clrMapOvr>
-</p:sld>
-</file>
-
-<file path=ppt/slides/slide6.xml><?xml version="1.0" encoding="utf-8"?>
-<p:sld xmlns:a="http://schemas.openxmlformats.org/drawingml/2006/main" xmlns:p="http://schemas.openxmlformats.org/presentationml/2006/main" xmlns:r="http://schemas.openxmlformats.org/officeDocument/2006/relationships">
-  <p:cSld>
-    <p:spTree>
-      <p:nvGrpSpPr>
-        <p:cNvPr id="1" name=""/>
-        <p:cNvGrpSpPr/>
-        <p:nvPr/>
-      </p:nvGrpSpPr>
-      <p:grpSpPr/>
-      <p:sp>
-        <p:nvSpPr>
-          <p:cNvPr id="2" name="Title 1"/>
-          <p:cNvSpPr>
-            <a:spLocks noGrp="1"/>
-          </p:cNvSpPr>
-          <p:nvPr>
-            <p:ph type="title"/>
-          </p:nvPr>
-        </p:nvSpPr>
-        <p:spPr/>
-        <p:txBody>
-          <a:bodyPr/>
-          <a:lstStyle/>
-          <a:p/>
-        </p:txBody>
-      </p:sp>
-      <p:sp>
-        <p:nvSpPr>
-          <p:cNvPr id="3" name="TextBox 2"/>
-          <p:cNvSpPr txBox="1"/>
-          <p:nvPr/>
-        </p:nvSpPr>
-        <p:spPr>
-          <a:xfrm>
-            <a:off x="457200" y="182880"/>
-            <a:ext cx="11277295" cy="548640"/>
-          </a:xfrm>
-          <a:prstGeom prst="rect">
-            <a:avLst/>
-          </a:prstGeom>
-          <a:noFill/>
-        </p:spPr>
-        <p:txBody>
-          <a:bodyPr wrap="none">
-            <a:spAutoFit/>
-          </a:bodyPr>
-          <a:lstStyle/>
-          <a:p>
-            <a:r>
-              <a:rPr sz="3600" b="1">
-                <a:solidFill>
-                  <a:srgbClr val="1F4E79"/>
-                </a:solidFill>
-              </a:rPr>
-              <a:t>Custom ISA Instruction: kc</a:t>
-            </a:r>
-          </a:p>
-        </p:txBody>
-      </p:sp>
-      <p:sp>
-        <p:nvSpPr>
-          <p:cNvPr id="4" name="TextBox 3"/>
-          <p:cNvSpPr txBox="1"/>
-          <p:nvPr/>
-        </p:nvSpPr>
-        <p:spPr>
-          <a:xfrm>
-            <a:off x="822960" y="1188720"/>
-            <a:ext cx="10545775" cy="5029200"/>
-          </a:xfrm>
-          <a:prstGeom prst="rect">
-            <a:avLst/>
-          </a:prstGeom>
-          <a:noFill/>
-        </p:spPr>
-        <p:txBody>
-          <a:bodyPr wrap="none">
-            <a:spAutoFit/>
-          </a:bodyPr>
-          <a:lstStyle/>
-          <a:p>
-            <a:pPr>
-              <a:defRPr sz="2200"/>
-            </a:pPr>
-            <a:r>
-              <a:t>Format: kc rd, imm20 (I-type)</a:t>
-            </a:r>
-          </a:p>
-          <a:p>
-            <a:pPr lvl="1">
-              <a:defRPr sz="1800"/>
-            </a:pPr>
-            <a:r>
-              <a:t>Immediate encodes token fragment</a:t>
-            </a:r>
-          </a:p>
-          <a:p>
-            <a:pPr>
-              <a:defRPr sz="2200"/>
-            </a:pPr>
-            <a:r>
-              <a:t>Semantics</a:t>
-            </a:r>
-          </a:p>
-          <a:p>
-            <a:pPr lvl="1">
-              <a:defRPr sz="1800"/>
-            </a:pPr>
-            <a:r>
-              <a:t>Triggers verification against protected key</a:t>
-            </a:r>
-          </a:p>
-          <a:p>
-            <a:pPr lvl="1">
-              <a:defRPr sz="1800"/>
-            </a:pPr>
-            <a:r>
-              <a:t>Updates exec_enable and debug_enable</a:t>
-            </a:r>
-          </a:p>
-          <a:p>
-            <a:pPr>
-              <a:defRPr sz="2200"/>
-            </a:pPr>
-            <a:r>
-              <a:t>Fail-stop on mismatch (halt state)</a:t>
-            </a:r>
-          </a:p>
-          <a:p>
-            <a:pPr>
-              <a:defRPr sz="2200"/>
-            </a:pPr>
-            <a:r>
-              <a:t>Placed in BootROM before untrusted code executes</a:t>
-            </a:r>
-          </a:p>
-        </p:txBody>
-      </p:sp>
-    </p:spTree>
-  </p:cSld>
-  <p:clrMapOvr>
-    <a:masterClrMapping/>
-  </p:clrMapOvr>
-</p:sld>
-</file>
-
-<file path=ppt/slides/slide7.xml><?xml version="1.0" encoding="utf-8"?>
-<p:sld xmlns:a="http://schemas.openxmlformats.org/drawingml/2006/main" xmlns:p="http://schemas.openxmlformats.org/presentationml/2006/main" xmlns:r="http://schemas.openxmlformats.org/officeDocument/2006/relationships">
-  <p:cSld>
-    <p:spTree>
-      <p:nvGrpSpPr>
-        <p:cNvPr id="1" name=""/>
-        <p:cNvGrpSpPr/>
-        <p:nvPr/>
-      </p:nvGrpSpPr>
-      <p:grpSpPr/>
-      <p:sp>
-        <p:nvSpPr>
-          <p:cNvPr id="2" name="Title 1"/>
-          <p:cNvSpPr>
-            <a:spLocks noGrp="1"/>
-          </p:cNvSpPr>
-          <p:nvPr>
-            <p:ph type="title"/>
-          </p:nvPr>
-        </p:nvSpPr>
-        <p:spPr/>
-        <p:txBody>
-          <a:bodyPr/>
-          <a:lstStyle/>
-          <a:p/>
-        </p:txBody>
-      </p:sp>
-      <p:sp>
-        <p:nvSpPr>
-          <p:cNvPr id="3" name="TextBox 2"/>
-          <p:cNvSpPr txBox="1"/>
-          <p:nvPr/>
-        </p:nvSpPr>
-        <p:spPr>
-          <a:xfrm>
-            <a:off x="457200" y="182880"/>
-            <a:ext cx="11277295" cy="548640"/>
-          </a:xfrm>
-          <a:prstGeom prst="rect">
-            <a:avLst/>
-          </a:prstGeom>
-          <a:noFill/>
-        </p:spPr>
-        <p:txBody>
-          <a:bodyPr wrap="none">
-            <a:spAutoFit/>
-          </a:bodyPr>
-          <a:lstStyle/>
-          <a:p>
-            <a:r>
-              <a:rPr sz="3600" b="1">
-                <a:solidFill>
-                  <a:srgbClr val="1F4E79"/>
-                </a:solidFill>
-              </a:rPr>
-              <a:t>Authorization Flow and FSM</a:t>
-            </a:r>
-          </a:p>
-        </p:txBody>
-      </p:sp>
-      <p:sp>
-        <p:nvSpPr>
-          <p:cNvPr id="4" name="TextBox 3"/>
-          <p:cNvSpPr txBox="1"/>
-          <p:nvPr/>
-        </p:nvSpPr>
-        <p:spPr>
-          <a:xfrm>
-            <a:off x="822960" y="1188720"/>
-            <a:ext cx="10545775" cy="5029200"/>
-          </a:xfrm>
-          <a:prstGeom prst="rect">
-            <a:avLst/>
-          </a:prstGeom>
-          <a:noFill/>
-        </p:spPr>
-        <p:txBody>
-          <a:bodyPr wrap="none">
-            <a:spAutoFit/>
-          </a:bodyPr>
-          <a:lstStyle/>
-          <a:p>
-            <a:pPr>
-              <a:defRPr sz="2200"/>
-            </a:pPr>
-            <a:r>
-              <a:t>Protocol</a:t>
-            </a:r>
-          </a:p>
-          <a:p>
-            <a:pPr lvl="1">
-              <a:defRPr sz="1800"/>
-            </a:pPr>
-            <a:r>
-              <a:t>Start -&gt; Key-1 -&gt; Key-2 -&gt; Key-3 -&gt; Enable -&gt; End</a:t>
-            </a:r>
-          </a:p>
-          <a:p>
-            <a:pPr>
-              <a:defRPr sz="2200"/>
-            </a:pPr>
-            <a:r>
-              <a:t>FSM states</a:t>
-            </a:r>
-          </a:p>
-          <a:p>
-            <a:pPr lvl="1">
-              <a:defRPr sz="1800"/>
-            </a:pPr>
-            <a:r>
-              <a:t>LOCKED -&gt; VERIFY -&gt; AUTHORIZED</a:t>
-            </a:r>
-          </a:p>
-          <a:p>
-            <a:pPr lvl="1">
-              <a:defRPr sz="1800"/>
-            </a:pPr>
-            <a:r>
-              <a:t>Mismatch leads to HALT</a:t>
-            </a:r>
-          </a:p>
-          <a:p>
-            <a:pPr>
-              <a:defRPr sz="2200"/>
-            </a:pPr>
-            <a:r>
-              <a:t>Debug is enabled only after successful match</a:t>
-            </a:r>
-          </a:p>
-        </p:txBody>
-      </p:sp>
-    </p:spTree>
-  </p:cSld>
-  <p:clrMapOvr>
-    <a:masterClrMapping/>
-  </p:clrMapOvr>
-</p:sld>
-</file>
-
-<file path=ppt/slides/slide8.xml><?xml version="1.0" encoding="utf-8"?>
-<p:sld xmlns:a="http://schemas.openxmlformats.org/drawingml/2006/main" xmlns:p="http://schemas.openxmlformats.org/presentationml/2006/main" xmlns:r="http://schemas.openxmlformats.org/officeDocument/2006/relationships">
-  <p:cSld>
-    <p:spTree>
-      <p:nvGrpSpPr>
-        <p:cNvPr id="1" name=""/>
-        <p:cNvGrpSpPr/>
-        <p:nvPr/>
-      </p:nvGrpSpPr>
-      <p:grpSpPr/>
-      <p:sp>
-        <p:nvSpPr>
-          <p:cNvPr id="2" name="Title 1"/>
-          <p:cNvSpPr>
-            <a:spLocks noGrp="1"/>
-          </p:cNvSpPr>
-          <p:nvPr>
-            <p:ph type="title"/>
-          </p:nvPr>
-        </p:nvSpPr>
-        <p:spPr/>
-        <p:txBody>
-          <a:bodyPr/>
-          <a:lstStyle/>
-          <a:p/>
-        </p:txBody>
-      </p:sp>
-      <p:sp>
-        <p:nvSpPr>
-          <p:cNvPr id="3" name="TextBox 2"/>
-          <p:cNvSpPr txBox="1"/>
-          <p:nvPr/>
-        </p:nvSpPr>
-        <p:spPr>
-          <a:xfrm>
-            <a:off x="457200" y="182880"/>
-            <a:ext cx="11277295" cy="548640"/>
-          </a:xfrm>
-          <a:prstGeom prst="rect">
-            <a:avLst/>
-          </a:prstGeom>
-          <a:noFill/>
-        </p:spPr>
-        <p:txBody>
-          <a:bodyPr wrap="none">
-            <a:spAutoFit/>
-          </a:bodyPr>
-          <a:lstStyle/>
-          <a:p>
-            <a:r>
-              <a:rPr sz="3600" b="1">
-                <a:solidFill>
-                  <a:srgbClr val="1F4E79"/>
-                </a:solidFill>
-              </a:rPr>
-              <a:t>Key Binding and Host Workflow</a:t>
-            </a:r>
-          </a:p>
-        </p:txBody>
-      </p:sp>
-      <p:sp>
-        <p:nvSpPr>
-          <p:cNvPr id="4" name="TextBox 3"/>
-          <p:cNvSpPr txBox="1"/>
-          <p:nvPr/>
-        </p:nvSpPr>
-        <p:spPr>
-          <a:xfrm>
-            <a:off x="822960" y="1188720"/>
-            <a:ext cx="10545775" cy="5029200"/>
-          </a:xfrm>
-          <a:prstGeom prst="rect">
-            <a:avLst/>
-          </a:prstGeom>
-          <a:noFill/>
-        </p:spPr>
-        <p:txBody>
-          <a:bodyPr wrap="none">
-            <a:spAutoFit/>
-          </a:bodyPr>
-          <a:lstStyle/>
-          <a:p>
-            <a:pPr>
-              <a:defRPr sz="2200"/>
-            </a:pPr>
-            <a:r>
-              <a:t>Key derived from host and device identifiers plus nonce</a:t>
-            </a:r>
-          </a:p>
-          <a:p>
-            <a:pPr>
-              <a:defRPr sz="2200"/>
-            </a:pPr>
-            <a:r>
-              <a:t>K = Trunc26(Mix(timestamp, machineID, hostUUID, deviceUUID, r))</a:t>
-            </a:r>
-          </a:p>
-          <a:p>
-            <a:pPr>
-              <a:defRPr sz="2200"/>
-            </a:pPr>
-            <a:r>
-              <a:t>Host database stores bindings and audit logs</a:t>
-            </a:r>
-          </a:p>
-          <a:p>
-            <a:pPr>
-              <a:defRPr sz="2200"/>
-            </a:pPr>
-            <a:r>
-              <a:t>Authorization sequence sent before privileged operations</a:t>
-            </a:r>
-          </a:p>
-        </p:txBody>
-      </p:sp>
-    </p:spTree>
-  </p:cSld>
-  <p:clrMapOvr>
-    <a:masterClrMapping/>
-  </p:clrMapOvr>
-</p:sld>
-</file>
-
-<file path=ppt/slides/slide9.xml><?xml version="1.0" encoding="utf-8"?>
-<p:sld xmlns:a="http://schemas.openxmlformats.org/drawingml/2006/main" xmlns:p="http://schemas.openxmlformats.org/presentationml/2006/main" xmlns:r="http://schemas.openxmlformats.org/officeDocument/2006/relationships">
-  <p:cSld>
-    <p:spTree>
-      <p:nvGrpSpPr>
-        <p:cNvPr id="1" name=""/>
-        <p:cNvGrpSpPr/>
-        <p:nvPr/>
-      </p:nvGrpSpPr>
-      <p:grpSpPr/>
-      <p:sp>
-        <p:nvSpPr>
-          <p:cNvPr id="2" name="Title 1"/>
-          <p:cNvSpPr>
-            <a:spLocks noGrp="1"/>
-          </p:cNvSpPr>
-          <p:nvPr>
-            <p:ph type="title"/>
-          </p:nvPr>
-        </p:nvSpPr>
-        <p:spPr/>
-        <p:txBody>
-          <a:bodyPr/>
-          <a:lstStyle/>
-          <a:p/>
-        </p:txBody>
-      </p:sp>
-      <p:sp>
-        <p:nvSpPr>
-          <p:cNvPr id="3" name="TextBox 2"/>
-          <p:cNvSpPr txBox="1"/>
-          <p:nvPr/>
-        </p:nvSpPr>
-        <p:spPr>
-          <a:xfrm>
-            <a:off x="457200" y="182880"/>
-            <a:ext cx="11277295" cy="548640"/>
-          </a:xfrm>
-          <a:prstGeom prst="rect">
-            <a:avLst/>
-          </a:prstGeom>
-          <a:noFill/>
-        </p:spPr>
-        <p:txBody>
-          <a:bodyPr wrap="none">
-            <a:spAutoFit/>
-          </a:bodyPr>
-          <a:lstStyle/>
-          <a:p>
-            <a:r>
-              <a:rPr sz="3600" b="1">
-                <a:solidFill>
-                  <a:srgbClr val="1F4E79"/>
-                </a:solidFill>
-              </a:rPr>
-              <a:t>Implementation and Toolchain Integration</a:t>
-            </a:r>
-          </a:p>
-        </p:txBody>
-      </p:sp>
-      <p:sp>
-        <p:nvSpPr>
-          <p:cNvPr id="4" name="TextBox 3"/>
-          <p:cNvSpPr txBox="1"/>
-          <p:nvPr/>
-        </p:nvSpPr>
-        <p:spPr>
-          <a:xfrm>
-            <a:off x="822960" y="1188720"/>
-            <a:ext cx="10545775" cy="5029200"/>
-          </a:xfrm>
-          <a:prstGeom prst="rect">
-            <a:avLst/>
-          </a:prstGeom>
-          <a:noFill/>
-        </p:spPr>
-        <p:txBody>
-          <a:bodyPr wrap="none">
-            <a:spAutoFit/>
-          </a:bodyPr>
-          <a:lstStyle/>
-          <a:p>
-            <a:pPr>
-              <a:defRPr sz="2200"/>
-            </a:pPr>
-            <a:r>
-              <a:t>Custom GCC/binutils emit kc from C and assembly</a:t>
-            </a:r>
-          </a:p>
-          <a:p>
-            <a:pPr>
-              <a:defRPr sz="2200"/>
-            </a:pPr>
-            <a:r>
-              <a:t>Protected NVM compare path not memory-mapped</a:t>
-            </a:r>
-          </a:p>
-          <a:p>
-            <a:pPr>
-              <a:defRPr sz="2200"/>
-            </a:pPr>
-            <a:r>
-              <a:t>Security FSM controls exec_enable and debug_enable</a:t>
-            </a:r>
-          </a:p>
-          <a:p>
-            <a:pPr>
-              <a:defRPr sz="2200"/>
-            </a:pPr>
-            <a:r>
-              <a:t>Host application supports compile, hex view, key match, and program</a:t>
-            </a:r>
-          </a:p>
-        </p:txBody>
-      </p:sp>
     </p:spTree>
   </p:cSld>
   <p:clrMapOvr>

</xml_diff>